<commit_message>
fix: duplicate download button, confidence badge color, fabricated designer dissent bug
</commit_message>
<xml_diff>
--- a/ARBoard_v10.pptx
+++ b/ARBoard_v10.pptx
@@ -17,9 +17,10 @@
     <p:sldId id="265" r:id="rId11"/>
     <p:sldId id="266" r:id="rId12"/>
     <p:sldId id="267" r:id="rId13"/>
+    <p:sldId id="268" r:id="rId14"/>
   </p:sldIdLst>
   <p:notesMasterIdLst>
-    <p:notesMasterId r:id="rId14"/>
+    <p:notesMasterId r:id="rId15"/>
   </p:notesMasterIdLst>
   <p:sldSz cx="9144000" cy="5143500"/>
   <p:notesSz cx="5143500" cy="9144000"/>
@@ -819,6 +820,94 @@
 </p:notes>
 </file>
 
+<file path=ppt/notesSlides/notesSlide13.xml><?xml version="1.0" encoding="utf-8"?>
+<p:notes xmlns:a="http://schemas.openxmlformats.org/drawingml/2006/main" xmlns:r="http://schemas.openxmlformats.org/officeDocument/2006/relationships" xmlns:p="http://schemas.openxmlformats.org/presentationml/2006/main">
+  <p:cSld>
+    <p:spTree>
+      <p:nvGrpSpPr>
+        <p:cNvPr id="1" name=""/>
+        <p:cNvGrpSpPr/>
+        <p:nvPr/>
+      </p:nvGrpSpPr>
+      <p:grpSpPr>
+        <a:xfrm>
+          <a:off x="0" y="0"/>
+          <a:ext cx="0" cy="0"/>
+          <a:chOff x="0" y="0"/>
+          <a:chExt cx="0" cy="0"/>
+        </a:xfrm>
+      </p:grpSpPr>
+      <p:sp>
+        <p:nvSpPr>
+          <p:cNvPr id="2" name="Slide Image Placeholder 1"/>
+          <p:cNvSpPr>
+            <a:spLocks noGrp="1" noRot="1" noChangeAspect="1"/>
+          </p:cNvSpPr>
+          <p:nvPr>
+            <p:ph type="sldImg"/>
+          </p:nvPr>
+        </p:nvSpPr>
+        <p:spPr/>
+      </p:sp>
+      <p:sp>
+        <p:nvSpPr>
+          <p:cNvPr id="3" name="Notes Placeholder 2"/>
+          <p:cNvSpPr>
+            <a:spLocks noGrp="1"/>
+          </p:cNvSpPr>
+          <p:nvPr>
+            <p:ph type="body" idx="1"/>
+          </p:nvPr>
+        </p:nvSpPr>
+        <p:spPr/>
+        <p:txBody>
+          <a:bodyPr/>
+          <a:lstStyle/>
+          <a:p>
+            <a:r>
+              <a:rPr lang="en-US" dirty="0"/>
+              <a:t>Schema went through 4 rounds of design challenge before a line of code was written. 7 queries defined first — schema designed to answer them. Write-before-run means traces survive orchestrator crashes.</a:t>
+            </a:r>
+            <a:endParaRPr lang="en-US" dirty="0"/>
+          </a:p>
+        </p:txBody>
+      </p:sp>
+      <p:sp>
+        <p:nvSpPr>
+          <p:cNvPr id="4" name="Slide Number Placeholder 3"/>
+          <p:cNvSpPr>
+            <a:spLocks noGrp="1"/>
+          </p:cNvSpPr>
+          <p:nvPr>
+            <p:ph type="sldNum" sz="quarter" idx="10"/>
+          </p:nvPr>
+        </p:nvSpPr>
+        <p:spPr/>
+        <p:txBody>
+          <a:bodyPr/>
+          <a:lstStyle/>
+          <a:p>
+            <a:fld id="{F7021451-1387-4CA6-816F-3879F97B5CBC}" type="slidenum">
+              <a:rPr lang="en-US"/>
+              <a:t>13</a:t>
+            </a:fld>
+            <a:endParaRPr lang="en-US"/>
+          </a:p>
+        </p:txBody>
+      </p:sp>
+    </p:spTree>
+    <p:extLst>
+      <p:ext uri="{BB962C8B-B14F-4D97-AF65-F5344CB8AC3E}">
+        <p14:creationId xmlns:p14="http://schemas.microsoft.com/office/powerpoint/2010/main" val="1024086991"/>
+      </p:ext>
+    </p:extLst>
+  </p:cSld>
+  <p:clrMapOvr>
+    <a:masterClrMapping/>
+  </p:clrMapOvr>
+</p:notes>
+</file>
+
 <file path=ppt/notesSlides/notesSlide2.xml><?xml version="1.0" encoding="utf-8"?>
 <p:notes xmlns:a="http://schemas.openxmlformats.org/drawingml/2006/main" xmlns:r="http://schemas.openxmlformats.org/officeDocument/2006/relationships" xmlns:p="http://schemas.openxmlformats.org/presentationml/2006/main">
   <p:cSld>
@@ -5509,6 +5598,1612 @@
 </p:sld>
 </file>
 
+<file path=ppt/slides/slide13.xml><?xml version="1.0" encoding="utf-8"?>
+<p:sld xmlns:a="http://schemas.openxmlformats.org/drawingml/2006/main" xmlns:r="http://schemas.openxmlformats.org/officeDocument/2006/relationships" xmlns:p="http://schemas.openxmlformats.org/presentationml/2006/main">
+  <p:cSld name="Slide 13">
+    <p:bg>
+      <p:bgPr>
+        <a:solidFill>
+          <a:srgbClr val="F8FAFC"/>
+        </a:solidFill>
+      </p:bgPr>
+    </p:bg>
+    <p:spTree>
+      <p:nvGrpSpPr>
+        <p:cNvPr id="1" name=""/>
+        <p:cNvGrpSpPr/>
+        <p:nvPr/>
+      </p:nvGrpSpPr>
+      <p:grpSpPr>
+        <a:xfrm>
+          <a:off x="0" y="0"/>
+          <a:ext cx="0" cy="0"/>
+          <a:chOff x="0" y="0"/>
+          <a:chExt cx="0" cy="0"/>
+        </a:xfrm>
+      </p:grpSpPr>
+      <p:sp>
+        <p:nvSpPr>
+          <p:cNvPr id="2" name="Shape 0"/>
+          <p:cNvSpPr/>
+          <p:nvPr/>
+        </p:nvSpPr>
+        <p:spPr>
+          <a:xfrm>
+            <a:off x="0" y="0"/>
+            <a:ext cx="9144000" cy="685800"/>
+          </a:xfrm>
+          <a:prstGeom prst="rect">
+            <a:avLst/>
+          </a:prstGeom>
+          <a:solidFill>
+            <a:srgbClr val="0F1F3D"/>
+          </a:solidFill>
+          <a:ln w="12700">
+            <a:solidFill>
+              <a:srgbClr val="0F1F3D"/>
+            </a:solidFill>
+            <a:prstDash val="solid"/>
+          </a:ln>
+        </p:spPr>
+      </p:sp>
+      <p:sp>
+        <p:nvSpPr>
+          <p:cNvPr id="3" name="Text 1"/>
+          <p:cNvSpPr/>
+          <p:nvPr/>
+        </p:nvSpPr>
+        <p:spPr>
+          <a:xfrm>
+            <a:off x="457200" y="0"/>
+            <a:ext cx="8229600" cy="685800"/>
+          </a:xfrm>
+          <a:prstGeom prst="rect">
+            <a:avLst/>
+          </a:prstGeom>
+          <a:noFill/>
+          <a:ln/>
+        </p:spPr>
+        <p:txBody>
+          <a:bodyPr wrap="square" rtlCol="0" anchor="ctr"/>
+          <a:lstStyle/>
+          <a:p>
+            <a:pPr indent="0" marL="0">
+              <a:buNone/>
+            </a:pPr>
+            <a:r>
+              <a:rPr lang="en-US" sz="2600" b="1" dirty="0">
+                <a:solidFill>
+                  <a:srgbClr val="FFFFFF"/>
+                </a:solidFill>
+                <a:latin typeface="Calibri" pitchFamily="34" charset="0"/>
+                <a:ea typeface="Calibri" pitchFamily="34" charset="-122"/>
+                <a:cs typeface="Calibri" pitchFamily="34" charset="-120"/>
+              </a:rPr>
+              <a:t>Session observability &amp; tracing</a:t>
+            </a:r>
+            <a:endParaRPr lang="en-US" sz="2600" dirty="0"/>
+          </a:p>
+        </p:txBody>
+      </p:sp>
+      <p:sp>
+        <p:nvSpPr>
+          <p:cNvPr id="4" name="Text 2"/>
+          <p:cNvSpPr/>
+          <p:nvPr/>
+        </p:nvSpPr>
+        <p:spPr>
+          <a:xfrm>
+            <a:off x="457200" y="777240"/>
+            <a:ext cx="8229600" cy="365760"/>
+          </a:xfrm>
+          <a:prstGeom prst="rect">
+            <a:avLst/>
+          </a:prstGeom>
+          <a:noFill/>
+          <a:ln/>
+        </p:spPr>
+        <p:txBody>
+          <a:bodyPr wrap="square" rtlCol="0" anchor="ctr"/>
+          <a:lstStyle/>
+          <a:p>
+            <a:pPr indent="0" marL="0">
+              <a:buNone/>
+            </a:pPr>
+            <a:r>
+              <a:rPr lang="en-US" sz="1300" dirty="0">
+                <a:solidFill>
+                  <a:srgbClr val="475569"/>
+                </a:solidFill>
+                <a:latin typeface="Calibri" pitchFamily="34" charset="0"/>
+                <a:ea typeface="Calibri" pitchFamily="34" charset="-122"/>
+                <a:cs typeface="Calibri" pitchFamily="34" charset="-120"/>
+              </a:rPr>
+              <a:t>Every ARBoard session is fully traced — what was injected, which agents ran, what they found, and a tamper-evident integrity hash.</a:t>
+            </a:r>
+            <a:endParaRPr lang="en-US" sz="1300" dirty="0"/>
+          </a:p>
+        </p:txBody>
+      </p:sp>
+      <p:sp>
+        <p:nvSpPr>
+          <p:cNvPr id="5" name="Shape 3"/>
+          <p:cNvSpPr/>
+          <p:nvPr/>
+        </p:nvSpPr>
+        <p:spPr>
+          <a:xfrm>
+            <a:off x="320040" y="1234440"/>
+            <a:ext cx="2743200" cy="365760"/>
+          </a:xfrm>
+          <a:prstGeom prst="roundRect">
+            <a:avLst>
+              <a:gd name="adj" fmla="val 20000"/>
+            </a:avLst>
+          </a:prstGeom>
+          <a:solidFill>
+            <a:srgbClr val="0F1F3D"/>
+          </a:solidFill>
+          <a:ln w="6350">
+            <a:solidFill>
+              <a:srgbClr val="14B8A6"/>
+            </a:solidFill>
+            <a:prstDash val="solid"/>
+          </a:ln>
+        </p:spPr>
+      </p:sp>
+      <p:sp>
+        <p:nvSpPr>
+          <p:cNvPr id="6" name="Text 4"/>
+          <p:cNvSpPr/>
+          <p:nvPr/>
+        </p:nvSpPr>
+        <p:spPr>
+          <a:xfrm>
+            <a:off x="320040" y="1234440"/>
+            <a:ext cx="2743200" cy="365760"/>
+          </a:xfrm>
+          <a:prstGeom prst="rect">
+            <a:avLst/>
+          </a:prstGeom>
+          <a:noFill/>
+          <a:ln/>
+        </p:spPr>
+        <p:txBody>
+          <a:bodyPr wrap="square" rtlCol="0" anchor="ctr"/>
+          <a:lstStyle/>
+          <a:p>
+            <a:pPr algn="ctr" indent="0" marL="0">
+              <a:buNone/>
+            </a:pPr>
+            <a:r>
+              <a:rPr lang="en-US" sz="1100" b="1" dirty="0">
+                <a:solidFill>
+                  <a:srgbClr val="FFFFFF"/>
+                </a:solidFill>
+                <a:latin typeface="Calibri" pitchFamily="34" charset="0"/>
+                <a:ea typeface="Calibri" pitchFamily="34" charset="-122"/>
+                <a:cs typeface="Calibri" pitchFamily="34" charset="-120"/>
+              </a:rPr>
+              <a:t>session_traces</a:t>
+            </a:r>
+            <a:endParaRPr lang="en-US" sz="1100" dirty="0"/>
+          </a:p>
+        </p:txBody>
+      </p:sp>
+      <p:sp>
+        <p:nvSpPr>
+          <p:cNvPr id="7" name="Shape 5"/>
+          <p:cNvSpPr/>
+          <p:nvPr/>
+        </p:nvSpPr>
+        <p:spPr>
+          <a:xfrm>
+            <a:off x="320040" y="1627632"/>
+            <a:ext cx="2743200" cy="1005840"/>
+          </a:xfrm>
+          <a:prstGeom prst="roundRect">
+            <a:avLst>
+              <a:gd name="adj" fmla="val 7273"/>
+            </a:avLst>
+          </a:prstGeom>
+          <a:solidFill>
+            <a:srgbClr val="FFFFFF"/>
+          </a:solidFill>
+          <a:ln w="12700">
+            <a:solidFill>
+              <a:srgbClr val="E2E8F0"/>
+            </a:solidFill>
+            <a:prstDash val="solid"/>
+          </a:ln>
+        </p:spPr>
+      </p:sp>
+      <p:sp>
+        <p:nvSpPr>
+          <p:cNvPr id="8" name="Text 6"/>
+          <p:cNvSpPr/>
+          <p:nvPr/>
+        </p:nvSpPr>
+        <p:spPr>
+          <a:xfrm>
+            <a:off x="320040" y="1664208"/>
+            <a:ext cx="2743200" cy="914400"/>
+          </a:xfrm>
+          <a:prstGeom prst="rect">
+            <a:avLst/>
+          </a:prstGeom>
+          <a:noFill/>
+          <a:ln/>
+        </p:spPr>
+        <p:txBody>
+          <a:bodyPr wrap="square" rtlCol="0" anchor="ctr"/>
+          <a:lstStyle/>
+          <a:p>
+            <a:pPr algn="ctr" indent="0" marL="0">
+              <a:buNone/>
+            </a:pPr>
+            <a:r>
+              <a:rPr lang="en-US" sz="1000" dirty="0">
+                <a:solidFill>
+                  <a:srgbClr val="475569"/>
+                </a:solidFill>
+                <a:latin typeface="Calibri" pitchFamily="34" charset="0"/>
+                <a:ea typeface="Calibri" pitchFamily="34" charset="-122"/>
+                <a:cs typeface="Calibri" pitchFamily="34" charset="-120"/>
+              </a:rPr>
+              <a:t>One row per session  ·  verdict · cost · tokens · hash  ·  resubmission chain · status</a:t>
+            </a:r>
+            <a:endParaRPr lang="en-US" sz="1000" dirty="0"/>
+          </a:p>
+        </p:txBody>
+      </p:sp>
+      <p:sp>
+        <p:nvSpPr>
+          <p:cNvPr id="9" name="Shape 7"/>
+          <p:cNvSpPr/>
+          <p:nvPr/>
+        </p:nvSpPr>
+        <p:spPr>
+          <a:xfrm>
+            <a:off x="3081528" y="1737360"/>
+            <a:ext cx="164592" cy="0"/>
+          </a:xfrm>
+          <a:prstGeom prst="line">
+            <a:avLst/>
+          </a:prstGeom>
+          <a:noFill/>
+          <a:ln w="19050">
+            <a:solidFill>
+              <a:srgbClr val="14B8A6"/>
+            </a:solidFill>
+            <a:prstDash val="solid"/>
+          </a:ln>
+        </p:spPr>
+      </p:sp>
+      <p:sp>
+        <p:nvSpPr>
+          <p:cNvPr id="10" name="Shape 8"/>
+          <p:cNvSpPr/>
+          <p:nvPr/>
+        </p:nvSpPr>
+        <p:spPr>
+          <a:xfrm>
+            <a:off x="3264408" y="1234440"/>
+            <a:ext cx="2743200" cy="365760"/>
+          </a:xfrm>
+          <a:prstGeom prst="roundRect">
+            <a:avLst>
+              <a:gd name="adj" fmla="val 20000"/>
+            </a:avLst>
+          </a:prstGeom>
+          <a:solidFill>
+            <a:srgbClr val="0F4C75"/>
+          </a:solidFill>
+          <a:ln w="6350">
+            <a:solidFill>
+              <a:srgbClr val="14B8A6"/>
+            </a:solidFill>
+            <a:prstDash val="solid"/>
+          </a:ln>
+        </p:spPr>
+      </p:sp>
+      <p:sp>
+        <p:nvSpPr>
+          <p:cNvPr id="11" name="Text 9"/>
+          <p:cNvSpPr/>
+          <p:nvPr/>
+        </p:nvSpPr>
+        <p:spPr>
+          <a:xfrm>
+            <a:off x="3264408" y="1234440"/>
+            <a:ext cx="2743200" cy="365760"/>
+          </a:xfrm>
+          <a:prstGeom prst="rect">
+            <a:avLst/>
+          </a:prstGeom>
+          <a:noFill/>
+          <a:ln/>
+        </p:spPr>
+        <p:txBody>
+          <a:bodyPr wrap="square" rtlCol="0" anchor="ctr"/>
+          <a:lstStyle/>
+          <a:p>
+            <a:pPr algn="ctr" indent="0" marL="0">
+              <a:buNone/>
+            </a:pPr>
+            <a:r>
+              <a:rPr lang="en-US" sz="1100" b="1" dirty="0">
+                <a:solidFill>
+                  <a:srgbClr val="FFFFFF"/>
+                </a:solidFill>
+                <a:latin typeface="Calibri" pitchFamily="34" charset="0"/>
+                <a:ea typeface="Calibri" pitchFamily="34" charset="-122"/>
+                <a:cs typeface="Calibri" pitchFamily="34" charset="-120"/>
+              </a:rPr>
+              <a:t>session_trace_agents</a:t>
+            </a:r>
+            <a:endParaRPr lang="en-US" sz="1100" dirty="0"/>
+          </a:p>
+        </p:txBody>
+      </p:sp>
+      <p:sp>
+        <p:nvSpPr>
+          <p:cNvPr id="12" name="Shape 10"/>
+          <p:cNvSpPr/>
+          <p:nvPr/>
+        </p:nvSpPr>
+        <p:spPr>
+          <a:xfrm>
+            <a:off x="3264408" y="1627632"/>
+            <a:ext cx="2743200" cy="1005840"/>
+          </a:xfrm>
+          <a:prstGeom prst="roundRect">
+            <a:avLst>
+              <a:gd name="adj" fmla="val 7273"/>
+            </a:avLst>
+          </a:prstGeom>
+          <a:solidFill>
+            <a:srgbClr val="FFFFFF"/>
+          </a:solidFill>
+          <a:ln w="12700">
+            <a:solidFill>
+              <a:srgbClr val="E2E8F0"/>
+            </a:solidFill>
+            <a:prstDash val="solid"/>
+          </a:ln>
+        </p:spPr>
+      </p:sp>
+      <p:sp>
+        <p:nvSpPr>
+          <p:cNvPr id="13" name="Text 11"/>
+          <p:cNvSpPr/>
+          <p:nvPr/>
+        </p:nvSpPr>
+        <p:spPr>
+          <a:xfrm>
+            <a:off x="3264408" y="1664208"/>
+            <a:ext cx="2743200" cy="914400"/>
+          </a:xfrm>
+          <a:prstGeom prst="rect">
+            <a:avLst/>
+          </a:prstGeom>
+          <a:noFill/>
+          <a:ln/>
+        </p:spPr>
+        <p:txBody>
+          <a:bodyPr wrap="square" rtlCol="0" anchor="ctr"/>
+          <a:lstStyle/>
+          <a:p>
+            <a:pPr algn="ctr" indent="0" marL="0">
+              <a:buNone/>
+            </a:pPr>
+            <a:r>
+              <a:rPr lang="en-US" sz="1000" dirty="0">
+                <a:solidFill>
+                  <a:srgbClr val="475569"/>
+                </a:solidFill>
+                <a:latin typeface="Calibri" pitchFamily="34" charset="0"/>
+                <a:ea typeface="Calibri" pitchFamily="34" charset="-122"/>
+                <a:cs typeface="Calibri" pitchFamily="34" charset="-120"/>
+              </a:rPr>
+              <a:t>One row per agent  ·  status · tokens · must-fix count  ·  sequence · round · dissent</a:t>
+            </a:r>
+            <a:endParaRPr lang="en-US" sz="1000" dirty="0"/>
+          </a:p>
+        </p:txBody>
+      </p:sp>
+      <p:sp>
+        <p:nvSpPr>
+          <p:cNvPr id="14" name="Shape 12"/>
+          <p:cNvSpPr/>
+          <p:nvPr/>
+        </p:nvSpPr>
+        <p:spPr>
+          <a:xfrm>
+            <a:off x="6025896" y="1737360"/>
+            <a:ext cx="164592" cy="0"/>
+          </a:xfrm>
+          <a:prstGeom prst="line">
+            <a:avLst/>
+          </a:prstGeom>
+          <a:noFill/>
+          <a:ln w="19050">
+            <a:solidFill>
+              <a:srgbClr val="14B8A6"/>
+            </a:solidFill>
+            <a:prstDash val="solid"/>
+          </a:ln>
+        </p:spPr>
+      </p:sp>
+      <p:sp>
+        <p:nvSpPr>
+          <p:cNvPr id="15" name="Shape 13"/>
+          <p:cNvSpPr/>
+          <p:nvPr/>
+        </p:nvSpPr>
+        <p:spPr>
+          <a:xfrm>
+            <a:off x="6208776" y="1234440"/>
+            <a:ext cx="2743200" cy="365760"/>
+          </a:xfrm>
+          <a:prstGeom prst="roundRect">
+            <a:avLst>
+              <a:gd name="adj" fmla="val 20000"/>
+            </a:avLst>
+          </a:prstGeom>
+          <a:solidFill>
+            <a:srgbClr val="0D9488"/>
+          </a:solidFill>
+          <a:ln w="6350">
+            <a:solidFill>
+              <a:srgbClr val="14B8A6"/>
+            </a:solidFill>
+            <a:prstDash val="solid"/>
+          </a:ln>
+        </p:spPr>
+      </p:sp>
+      <p:sp>
+        <p:nvSpPr>
+          <p:cNvPr id="16" name="Text 14"/>
+          <p:cNvSpPr/>
+          <p:nvPr/>
+        </p:nvSpPr>
+        <p:spPr>
+          <a:xfrm>
+            <a:off x="6208776" y="1234440"/>
+            <a:ext cx="2743200" cy="365760"/>
+          </a:xfrm>
+          <a:prstGeom prst="rect">
+            <a:avLst/>
+          </a:prstGeom>
+          <a:noFill/>
+          <a:ln/>
+        </p:spPr>
+        <p:txBody>
+          <a:bodyPr wrap="square" rtlCol="0" anchor="ctr"/>
+          <a:lstStyle/>
+          <a:p>
+            <a:pPr algn="ctr" indent="0" marL="0">
+              <a:buNone/>
+            </a:pPr>
+            <a:r>
+              <a:rPr lang="en-US" sz="1100" b="1" dirty="0">
+                <a:solidFill>
+                  <a:srgbClr val="FFFFFF"/>
+                </a:solidFill>
+                <a:latin typeface="Calibri" pitchFamily="34" charset="0"/>
+                <a:ea typeface="Calibri" pitchFamily="34" charset="-122"/>
+                <a:cs typeface="Calibri" pitchFamily="34" charset="-120"/>
+              </a:rPr>
+              <a:t>session_trace_injections</a:t>
+            </a:r>
+            <a:endParaRPr lang="en-US" sz="1100" dirty="0"/>
+          </a:p>
+        </p:txBody>
+      </p:sp>
+      <p:sp>
+        <p:nvSpPr>
+          <p:cNvPr id="17" name="Shape 15"/>
+          <p:cNvSpPr/>
+          <p:nvPr/>
+        </p:nvSpPr>
+        <p:spPr>
+          <a:xfrm>
+            <a:off x="6208776" y="1627632"/>
+            <a:ext cx="2743200" cy="1005840"/>
+          </a:xfrm>
+          <a:prstGeom prst="roundRect">
+            <a:avLst>
+              <a:gd name="adj" fmla="val 7273"/>
+            </a:avLst>
+          </a:prstGeom>
+          <a:solidFill>
+            <a:srgbClr val="FFFFFF"/>
+          </a:solidFill>
+          <a:ln w="12700">
+            <a:solidFill>
+              <a:srgbClr val="E2E8F0"/>
+            </a:solidFill>
+            <a:prstDash val="solid"/>
+          </a:ln>
+        </p:spPr>
+      </p:sp>
+      <p:sp>
+        <p:nvSpPr>
+          <p:cNvPr id="18" name="Text 16"/>
+          <p:cNvSpPr/>
+          <p:nvPr/>
+        </p:nvSpPr>
+        <p:spPr>
+          <a:xfrm>
+            <a:off x="6208776" y="1664208"/>
+            <a:ext cx="2743200" cy="914400"/>
+          </a:xfrm>
+          <a:prstGeom prst="rect">
+            <a:avLst/>
+          </a:prstGeom>
+          <a:noFill/>
+          <a:ln/>
+        </p:spPr>
+        <p:txBody>
+          <a:bodyPr wrap="square" rtlCol="0" anchor="ctr"/>
+          <a:lstStyle/>
+          <a:p>
+            <a:pPr algn="ctr" indent="0" marL="0">
+              <a:buNone/>
+            </a:pPr>
+            <a:r>
+              <a:rPr lang="en-US" sz="1000" dirty="0">
+                <a:solidFill>
+                  <a:srgbClr val="475569"/>
+                </a:solidFill>
+                <a:latin typeface="Calibri" pitchFamily="34" charset="0"/>
+                <a:ea typeface="Calibri" pitchFamily="34" charset="-122"/>
+                <a:cs typeface="Calibri" pitchFamily="34" charset="-120"/>
+              </a:rPr>
+              <a:t>One row per grounding layer  ·  type · file · keywords matched  ·  token estimate</a:t>
+            </a:r>
+            <a:endParaRPr lang="en-US" sz="1000" dirty="0"/>
+          </a:p>
+        </p:txBody>
+      </p:sp>
+      <p:sp>
+        <p:nvSpPr>
+          <p:cNvPr id="19" name="Text 17"/>
+          <p:cNvSpPr/>
+          <p:nvPr/>
+        </p:nvSpPr>
+        <p:spPr>
+          <a:xfrm>
+            <a:off x="320040" y="2761488"/>
+            <a:ext cx="8503920" cy="292608"/>
+          </a:xfrm>
+          <a:prstGeom prst="rect">
+            <a:avLst/>
+          </a:prstGeom>
+          <a:noFill/>
+          <a:ln/>
+        </p:spPr>
+        <p:txBody>
+          <a:bodyPr wrap="square" rtlCol="0" anchor="ctr"/>
+          <a:lstStyle/>
+          <a:p>
+            <a:pPr indent="0" marL="0">
+              <a:buNone/>
+            </a:pPr>
+            <a:r>
+              <a:rPr lang="en-US" sz="1300" b="1" dirty="0">
+                <a:solidFill>
+                  <a:srgbClr val="1E293B"/>
+                </a:solidFill>
+                <a:latin typeface="Calibri" pitchFamily="34" charset="0"/>
+                <a:ea typeface="Calibri" pitchFamily="34" charset="-122"/>
+                <a:cs typeface="Calibri" pitchFamily="34" charset="-120"/>
+              </a:rPr>
+              <a:t>7 analytics queries — designed first, schema built to answer them</a:t>
+            </a:r>
+            <a:endParaRPr lang="en-US" sz="1300" dirty="0"/>
+          </a:p>
+        </p:txBody>
+      </p:sp>
+      <p:sp>
+        <p:nvSpPr>
+          <p:cNvPr id="20" name="Shape 18"/>
+          <p:cNvSpPr/>
+          <p:nvPr/>
+        </p:nvSpPr>
+        <p:spPr>
+          <a:xfrm>
+            <a:off x="320040" y="3108960"/>
+            <a:ext cx="4206240" cy="292608"/>
+          </a:xfrm>
+          <a:prstGeom prst="roundRect">
+            <a:avLst>
+              <a:gd name="adj" fmla="val 15625"/>
+            </a:avLst>
+          </a:prstGeom>
+          <a:solidFill>
+            <a:srgbClr val="FFFFFF"/>
+          </a:solidFill>
+          <a:ln w="6350">
+            <a:solidFill>
+              <a:srgbClr val="E2E8F0"/>
+            </a:solidFill>
+            <a:prstDash val="solid"/>
+          </a:ln>
+        </p:spPr>
+      </p:sp>
+      <p:sp>
+        <p:nvSpPr>
+          <p:cNvPr id="21" name="Shape 19"/>
+          <p:cNvSpPr/>
+          <p:nvPr/>
+        </p:nvSpPr>
+        <p:spPr>
+          <a:xfrm>
+            <a:off x="393192" y="3154680"/>
+            <a:ext cx="384048" cy="201168"/>
+          </a:xfrm>
+          <a:prstGeom prst="roundRect">
+            <a:avLst>
+              <a:gd name="adj" fmla="val 18182"/>
+            </a:avLst>
+          </a:prstGeom>
+          <a:solidFill>
+            <a:srgbClr val="0D9488"/>
+          </a:solidFill>
+          <a:ln w="12700">
+            <a:solidFill>
+              <a:srgbClr val="0D9488"/>
+            </a:solidFill>
+            <a:prstDash val="solid"/>
+          </a:ln>
+        </p:spPr>
+      </p:sp>
+      <p:sp>
+        <p:nvSpPr>
+          <p:cNvPr id="22" name="Text 20"/>
+          <p:cNvSpPr/>
+          <p:nvPr/>
+        </p:nvSpPr>
+        <p:spPr>
+          <a:xfrm>
+            <a:off x="393192" y="3154680"/>
+            <a:ext cx="384048" cy="201168"/>
+          </a:xfrm>
+          <a:prstGeom prst="rect">
+            <a:avLst/>
+          </a:prstGeom>
+          <a:noFill/>
+          <a:ln/>
+        </p:spPr>
+        <p:txBody>
+          <a:bodyPr wrap="square" rtlCol="0" anchor="ctr"/>
+          <a:lstStyle/>
+          <a:p>
+            <a:pPr algn="ctr" indent="0" marL="0">
+              <a:buNone/>
+            </a:pPr>
+            <a:r>
+              <a:rPr lang="en-US" sz="800" b="1" dirty="0">
+                <a:solidFill>
+                  <a:srgbClr val="FFFFFF"/>
+                </a:solidFill>
+                <a:latin typeface="Calibri" pitchFamily="34" charset="0"/>
+                <a:ea typeface="Calibri" pitchFamily="34" charset="-122"/>
+                <a:cs typeface="Calibri" pitchFamily="34" charset="-120"/>
+              </a:rPr>
+              <a:t>Q1</a:t>
+            </a:r>
+            <a:endParaRPr lang="en-US" sz="800" dirty="0"/>
+          </a:p>
+        </p:txBody>
+      </p:sp>
+      <p:sp>
+        <p:nvSpPr>
+          <p:cNvPr id="23" name="Text 21"/>
+          <p:cNvSpPr/>
+          <p:nvPr/>
+        </p:nvSpPr>
+        <p:spPr>
+          <a:xfrm>
+            <a:off x="850392" y="3108960"/>
+            <a:ext cx="3657600" cy="292608"/>
+          </a:xfrm>
+          <a:prstGeom prst="rect">
+            <a:avLst/>
+          </a:prstGeom>
+          <a:noFill/>
+          <a:ln/>
+        </p:spPr>
+        <p:txBody>
+          <a:bodyPr wrap="square" rtlCol="0" anchor="ctr"/>
+          <a:lstStyle/>
+          <a:p>
+            <a:pPr indent="0" marL="0">
+              <a:buNone/>
+            </a:pPr>
+            <a:r>
+              <a:rPr lang="en-US" sz="1000" dirty="0">
+                <a:solidFill>
+                  <a:srgbClr val="475569"/>
+                </a:solidFill>
+                <a:latin typeface="Calibri" pitchFamily="34" charset="0"/>
+                <a:ea typeface="Calibri" pitchFamily="34" charset="-122"/>
+                <a:cs typeface="Calibri" pitchFamily="34" charset="-120"/>
+              </a:rPr>
+              <a:t>Grounding layers + token cost per agent per session</a:t>
+            </a:r>
+            <a:endParaRPr lang="en-US" sz="1000" dirty="0"/>
+          </a:p>
+        </p:txBody>
+      </p:sp>
+      <p:sp>
+        <p:nvSpPr>
+          <p:cNvPr id="24" name="Shape 22"/>
+          <p:cNvSpPr/>
+          <p:nvPr/>
+        </p:nvSpPr>
+        <p:spPr>
+          <a:xfrm>
+            <a:off x="320040" y="3456432"/>
+            <a:ext cx="4206240" cy="292608"/>
+          </a:xfrm>
+          <a:prstGeom prst="roundRect">
+            <a:avLst>
+              <a:gd name="adj" fmla="val 15625"/>
+            </a:avLst>
+          </a:prstGeom>
+          <a:solidFill>
+            <a:srgbClr val="F8FAFC"/>
+          </a:solidFill>
+          <a:ln w="6350">
+            <a:solidFill>
+              <a:srgbClr val="E2E8F0"/>
+            </a:solidFill>
+            <a:prstDash val="solid"/>
+          </a:ln>
+        </p:spPr>
+      </p:sp>
+      <p:sp>
+        <p:nvSpPr>
+          <p:cNvPr id="25" name="Shape 23"/>
+          <p:cNvSpPr/>
+          <p:nvPr/>
+        </p:nvSpPr>
+        <p:spPr>
+          <a:xfrm>
+            <a:off x="393192" y="3502152"/>
+            <a:ext cx="384048" cy="201168"/>
+          </a:xfrm>
+          <a:prstGeom prst="roundRect">
+            <a:avLst>
+              <a:gd name="adj" fmla="val 18182"/>
+            </a:avLst>
+          </a:prstGeom>
+          <a:solidFill>
+            <a:srgbClr val="0D9488"/>
+          </a:solidFill>
+          <a:ln w="12700">
+            <a:solidFill>
+              <a:srgbClr val="0D9488"/>
+            </a:solidFill>
+            <a:prstDash val="solid"/>
+          </a:ln>
+        </p:spPr>
+      </p:sp>
+      <p:sp>
+        <p:nvSpPr>
+          <p:cNvPr id="26" name="Text 24"/>
+          <p:cNvSpPr/>
+          <p:nvPr/>
+        </p:nvSpPr>
+        <p:spPr>
+          <a:xfrm>
+            <a:off x="393192" y="3502152"/>
+            <a:ext cx="384048" cy="201168"/>
+          </a:xfrm>
+          <a:prstGeom prst="rect">
+            <a:avLst/>
+          </a:prstGeom>
+          <a:noFill/>
+          <a:ln/>
+        </p:spPr>
+        <p:txBody>
+          <a:bodyPr wrap="square" rtlCol="0" anchor="ctr"/>
+          <a:lstStyle/>
+          <a:p>
+            <a:pPr algn="ctr" indent="0" marL="0">
+              <a:buNone/>
+            </a:pPr>
+            <a:r>
+              <a:rPr lang="en-US" sz="800" b="1" dirty="0">
+                <a:solidFill>
+                  <a:srgbClr val="FFFFFF"/>
+                </a:solidFill>
+                <a:latin typeface="Calibri" pitchFamily="34" charset="0"/>
+                <a:ea typeface="Calibri" pitchFamily="34" charset="-122"/>
+                <a:cs typeface="Calibri" pitchFamily="34" charset="-120"/>
+              </a:rPr>
+              <a:t>Q2</a:t>
+            </a:r>
+            <a:endParaRPr lang="en-US" sz="800" dirty="0"/>
+          </a:p>
+        </p:txBody>
+      </p:sp>
+      <p:sp>
+        <p:nvSpPr>
+          <p:cNvPr id="27" name="Text 25"/>
+          <p:cNvSpPr/>
+          <p:nvPr/>
+        </p:nvSpPr>
+        <p:spPr>
+          <a:xfrm>
+            <a:off x="850392" y="3456432"/>
+            <a:ext cx="3657600" cy="292608"/>
+          </a:xfrm>
+          <a:prstGeom prst="rect">
+            <a:avLst/>
+          </a:prstGeom>
+          <a:noFill/>
+          <a:ln/>
+        </p:spPr>
+        <p:txBody>
+          <a:bodyPr wrap="square" rtlCol="0" anchor="ctr"/>
+          <a:lstStyle/>
+          <a:p>
+            <a:pPr indent="0" marL="0">
+              <a:buNone/>
+            </a:pPr>
+            <a:r>
+              <a:rPr lang="en-US" sz="1000" dirty="0">
+                <a:solidFill>
+                  <a:srgbClr val="475569"/>
+                </a:solidFill>
+                <a:latin typeface="Calibri" pitchFamily="34" charset="0"/>
+                <a:ea typeface="Calibri" pitchFamily="34" charset="-122"/>
+                <a:cs typeface="Calibri" pitchFamily="34" charset="-120"/>
+              </a:rPr>
+              <a:t>Most / least triggered cross-cutting skills this month</a:t>
+            </a:r>
+            <a:endParaRPr lang="en-US" sz="1000" dirty="0"/>
+          </a:p>
+        </p:txBody>
+      </p:sp>
+      <p:sp>
+        <p:nvSpPr>
+          <p:cNvPr id="28" name="Shape 26"/>
+          <p:cNvSpPr/>
+          <p:nvPr/>
+        </p:nvSpPr>
+        <p:spPr>
+          <a:xfrm>
+            <a:off x="320040" y="3803904"/>
+            <a:ext cx="4206240" cy="292608"/>
+          </a:xfrm>
+          <a:prstGeom prst="roundRect">
+            <a:avLst>
+              <a:gd name="adj" fmla="val 15625"/>
+            </a:avLst>
+          </a:prstGeom>
+          <a:solidFill>
+            <a:srgbClr val="FFFFFF"/>
+          </a:solidFill>
+          <a:ln w="6350">
+            <a:solidFill>
+              <a:srgbClr val="E2E8F0"/>
+            </a:solidFill>
+            <a:prstDash val="solid"/>
+          </a:ln>
+        </p:spPr>
+      </p:sp>
+      <p:sp>
+        <p:nvSpPr>
+          <p:cNvPr id="29" name="Shape 27"/>
+          <p:cNvSpPr/>
+          <p:nvPr/>
+        </p:nvSpPr>
+        <p:spPr>
+          <a:xfrm>
+            <a:off x="393192" y="3849624"/>
+            <a:ext cx="384048" cy="201168"/>
+          </a:xfrm>
+          <a:prstGeom prst="roundRect">
+            <a:avLst>
+              <a:gd name="adj" fmla="val 18182"/>
+            </a:avLst>
+          </a:prstGeom>
+          <a:solidFill>
+            <a:srgbClr val="0D9488"/>
+          </a:solidFill>
+          <a:ln w="12700">
+            <a:solidFill>
+              <a:srgbClr val="0D9488"/>
+            </a:solidFill>
+            <a:prstDash val="solid"/>
+          </a:ln>
+        </p:spPr>
+      </p:sp>
+      <p:sp>
+        <p:nvSpPr>
+          <p:cNvPr id="30" name="Text 28"/>
+          <p:cNvSpPr/>
+          <p:nvPr/>
+        </p:nvSpPr>
+        <p:spPr>
+          <a:xfrm>
+            <a:off x="393192" y="3849624"/>
+            <a:ext cx="384048" cy="201168"/>
+          </a:xfrm>
+          <a:prstGeom prst="rect">
+            <a:avLst/>
+          </a:prstGeom>
+          <a:noFill/>
+          <a:ln/>
+        </p:spPr>
+        <p:txBody>
+          <a:bodyPr wrap="square" rtlCol="0" anchor="ctr"/>
+          <a:lstStyle/>
+          <a:p>
+            <a:pPr algn="ctr" indent="0" marL="0">
+              <a:buNone/>
+            </a:pPr>
+            <a:r>
+              <a:rPr lang="en-US" sz="800" b="1" dirty="0">
+                <a:solidFill>
+                  <a:srgbClr val="FFFFFF"/>
+                </a:solidFill>
+                <a:latin typeface="Calibri" pitchFamily="34" charset="0"/>
+                <a:ea typeface="Calibri" pitchFamily="34" charset="-122"/>
+                <a:cs typeface="Calibri" pitchFamily="34" charset="-120"/>
+              </a:rPr>
+              <a:t>Q3</a:t>
+            </a:r>
+            <a:endParaRPr lang="en-US" sz="800" dirty="0"/>
+          </a:p>
+        </p:txBody>
+      </p:sp>
+      <p:sp>
+        <p:nvSpPr>
+          <p:cNvPr id="31" name="Text 29"/>
+          <p:cNvSpPr/>
+          <p:nvPr/>
+        </p:nvSpPr>
+        <p:spPr>
+          <a:xfrm>
+            <a:off x="850392" y="3803904"/>
+            <a:ext cx="3657600" cy="292608"/>
+          </a:xfrm>
+          <a:prstGeom prst="rect">
+            <a:avLst/>
+          </a:prstGeom>
+          <a:noFill/>
+          <a:ln/>
+        </p:spPr>
+        <p:txBody>
+          <a:bodyPr wrap="square" rtlCol="0" anchor="ctr"/>
+          <a:lstStyle/>
+          <a:p>
+            <a:pPr indent="0" marL="0">
+              <a:buNone/>
+            </a:pPr>
+            <a:r>
+              <a:rPr lang="en-US" sz="1000" dirty="0">
+                <a:solidFill>
+                  <a:srgbClr val="475569"/>
+                </a:solidFill>
+                <a:latin typeface="Calibri" pitchFamily="34" charset="0"/>
+                <a:ea typeface="Calibri" pitchFamily="34" charset="-122"/>
+                <a:cs typeface="Calibri" pitchFamily="34" charset="-120"/>
+              </a:rPr>
+              <a:t>Agent failure rate and error patterns</a:t>
+            </a:r>
+            <a:endParaRPr lang="en-US" sz="1000" dirty="0"/>
+          </a:p>
+        </p:txBody>
+      </p:sp>
+      <p:sp>
+        <p:nvSpPr>
+          <p:cNvPr id="32" name="Shape 30"/>
+          <p:cNvSpPr/>
+          <p:nvPr/>
+        </p:nvSpPr>
+        <p:spPr>
+          <a:xfrm>
+            <a:off x="320040" y="4151376"/>
+            <a:ext cx="4206240" cy="292608"/>
+          </a:xfrm>
+          <a:prstGeom prst="roundRect">
+            <a:avLst>
+              <a:gd name="adj" fmla="val 15625"/>
+            </a:avLst>
+          </a:prstGeom>
+          <a:solidFill>
+            <a:srgbClr val="F8FAFC"/>
+          </a:solidFill>
+          <a:ln w="6350">
+            <a:solidFill>
+              <a:srgbClr val="E2E8F0"/>
+            </a:solidFill>
+            <a:prstDash val="solid"/>
+          </a:ln>
+        </p:spPr>
+      </p:sp>
+      <p:sp>
+        <p:nvSpPr>
+          <p:cNvPr id="33" name="Shape 31"/>
+          <p:cNvSpPr/>
+          <p:nvPr/>
+        </p:nvSpPr>
+        <p:spPr>
+          <a:xfrm>
+            <a:off x="393192" y="4197096"/>
+            <a:ext cx="384048" cy="201168"/>
+          </a:xfrm>
+          <a:prstGeom prst="roundRect">
+            <a:avLst>
+              <a:gd name="adj" fmla="val 18182"/>
+            </a:avLst>
+          </a:prstGeom>
+          <a:solidFill>
+            <a:srgbClr val="0D9488"/>
+          </a:solidFill>
+          <a:ln w="12700">
+            <a:solidFill>
+              <a:srgbClr val="0D9488"/>
+            </a:solidFill>
+            <a:prstDash val="solid"/>
+          </a:ln>
+        </p:spPr>
+      </p:sp>
+      <p:sp>
+        <p:nvSpPr>
+          <p:cNvPr id="34" name="Text 32"/>
+          <p:cNvSpPr/>
+          <p:nvPr/>
+        </p:nvSpPr>
+        <p:spPr>
+          <a:xfrm>
+            <a:off x="393192" y="4197096"/>
+            <a:ext cx="384048" cy="201168"/>
+          </a:xfrm>
+          <a:prstGeom prst="rect">
+            <a:avLst/>
+          </a:prstGeom>
+          <a:noFill/>
+          <a:ln/>
+        </p:spPr>
+        <p:txBody>
+          <a:bodyPr wrap="square" rtlCol="0" anchor="ctr"/>
+          <a:lstStyle/>
+          <a:p>
+            <a:pPr algn="ctr" indent="0" marL="0">
+              <a:buNone/>
+            </a:pPr>
+            <a:r>
+              <a:rPr lang="en-US" sz="800" b="1" dirty="0">
+                <a:solidFill>
+                  <a:srgbClr val="FFFFFF"/>
+                </a:solidFill>
+                <a:latin typeface="Calibri" pitchFamily="34" charset="0"/>
+                <a:ea typeface="Calibri" pitchFamily="34" charset="-122"/>
+                <a:cs typeface="Calibri" pitchFamily="34" charset="-120"/>
+              </a:rPr>
+              <a:t>Q4</a:t>
+            </a:r>
+            <a:endParaRPr lang="en-US" sz="800" dirty="0"/>
+          </a:p>
+        </p:txBody>
+      </p:sp>
+      <p:sp>
+        <p:nvSpPr>
+          <p:cNvPr id="35" name="Text 33"/>
+          <p:cNvSpPr/>
+          <p:nvPr/>
+        </p:nvSpPr>
+        <p:spPr>
+          <a:xfrm>
+            <a:off x="850392" y="4151376"/>
+            <a:ext cx="3657600" cy="292608"/>
+          </a:xfrm>
+          <a:prstGeom prst="rect">
+            <a:avLst/>
+          </a:prstGeom>
+          <a:noFill/>
+          <a:ln/>
+        </p:spPr>
+        <p:txBody>
+          <a:bodyPr wrap="square" rtlCol="0" anchor="ctr"/>
+          <a:lstStyle/>
+          <a:p>
+            <a:pPr indent="0" marL="0">
+              <a:buNone/>
+            </a:pPr>
+            <a:r>
+              <a:rPr lang="en-US" sz="1000" dirty="0">
+                <a:solidFill>
+                  <a:srgbClr val="475569"/>
+                </a:solidFill>
+                <a:latin typeface="Calibri" pitchFamily="34" charset="0"/>
+                <a:ea typeface="Calibri" pitchFamily="34" charset="-122"/>
+                <a:cs typeface="Calibri" pitchFamily="34" charset="-120"/>
+              </a:rPr>
+              <a:t>Finding changes across document resubmissions</a:t>
+            </a:r>
+            <a:endParaRPr lang="en-US" sz="1000" dirty="0"/>
+          </a:p>
+        </p:txBody>
+      </p:sp>
+      <p:sp>
+        <p:nvSpPr>
+          <p:cNvPr id="36" name="Shape 34"/>
+          <p:cNvSpPr/>
+          <p:nvPr/>
+        </p:nvSpPr>
+        <p:spPr>
+          <a:xfrm>
+            <a:off x="4754880" y="3108960"/>
+            <a:ext cx="4206240" cy="292608"/>
+          </a:xfrm>
+          <a:prstGeom prst="roundRect">
+            <a:avLst>
+              <a:gd name="adj" fmla="val 15625"/>
+            </a:avLst>
+          </a:prstGeom>
+          <a:solidFill>
+            <a:srgbClr val="FFFFFF"/>
+          </a:solidFill>
+          <a:ln w="6350">
+            <a:solidFill>
+              <a:srgbClr val="E2E8F0"/>
+            </a:solidFill>
+            <a:prstDash val="solid"/>
+          </a:ln>
+        </p:spPr>
+      </p:sp>
+      <p:sp>
+        <p:nvSpPr>
+          <p:cNvPr id="37" name="Shape 35"/>
+          <p:cNvSpPr/>
+          <p:nvPr/>
+        </p:nvSpPr>
+        <p:spPr>
+          <a:xfrm>
+            <a:off x="4828032" y="3154680"/>
+            <a:ext cx="384048" cy="201168"/>
+          </a:xfrm>
+          <a:prstGeom prst="roundRect">
+            <a:avLst>
+              <a:gd name="adj" fmla="val 18182"/>
+            </a:avLst>
+          </a:prstGeom>
+          <a:solidFill>
+            <a:srgbClr val="0D9488"/>
+          </a:solidFill>
+          <a:ln w="12700">
+            <a:solidFill>
+              <a:srgbClr val="0D9488"/>
+            </a:solidFill>
+            <a:prstDash val="solid"/>
+          </a:ln>
+        </p:spPr>
+      </p:sp>
+      <p:sp>
+        <p:nvSpPr>
+          <p:cNvPr id="38" name="Text 36"/>
+          <p:cNvSpPr/>
+          <p:nvPr/>
+        </p:nvSpPr>
+        <p:spPr>
+          <a:xfrm>
+            <a:off x="4828032" y="3154680"/>
+            <a:ext cx="384048" cy="201168"/>
+          </a:xfrm>
+          <a:prstGeom prst="rect">
+            <a:avLst/>
+          </a:prstGeom>
+          <a:noFill/>
+          <a:ln/>
+        </p:spPr>
+        <p:txBody>
+          <a:bodyPr wrap="square" rtlCol="0" anchor="ctr"/>
+          <a:lstStyle/>
+          <a:p>
+            <a:pPr algn="ctr" indent="0" marL="0">
+              <a:buNone/>
+            </a:pPr>
+            <a:r>
+              <a:rPr lang="en-US" sz="800" b="1" dirty="0">
+                <a:solidFill>
+                  <a:srgbClr val="FFFFFF"/>
+                </a:solidFill>
+                <a:latin typeface="Calibri" pitchFamily="34" charset="0"/>
+                <a:ea typeface="Calibri" pitchFamily="34" charset="-122"/>
+                <a:cs typeface="Calibri" pitchFamily="34" charset="-120"/>
+              </a:rPr>
+              <a:t>Q5</a:t>
+            </a:r>
+            <a:endParaRPr lang="en-US" sz="800" dirty="0"/>
+          </a:p>
+        </p:txBody>
+      </p:sp>
+      <p:sp>
+        <p:nvSpPr>
+          <p:cNvPr id="39" name="Text 37"/>
+          <p:cNvSpPr/>
+          <p:nvPr/>
+        </p:nvSpPr>
+        <p:spPr>
+          <a:xfrm>
+            <a:off x="5285232" y="3108960"/>
+            <a:ext cx="3657600" cy="292608"/>
+          </a:xfrm>
+          <a:prstGeom prst="rect">
+            <a:avLst/>
+          </a:prstGeom>
+          <a:noFill/>
+          <a:ln/>
+        </p:spPr>
+        <p:txBody>
+          <a:bodyPr wrap="square" rtlCol="0" anchor="ctr"/>
+          <a:lstStyle/>
+          <a:p>
+            <a:pPr indent="0" marL="0">
+              <a:buNone/>
+            </a:pPr>
+            <a:r>
+              <a:rPr lang="en-US" sz="1000" dirty="0">
+                <a:solidFill>
+                  <a:srgbClr val="475569"/>
+                </a:solidFill>
+                <a:latin typeface="Calibri" pitchFamily="34" charset="0"/>
+                <a:ea typeface="Calibri" pitchFamily="34" charset="-122"/>
+                <a:cs typeface="Calibri" pitchFamily="34" charset="-120"/>
+              </a:rPr>
+              <a:t>Sessions deviating most from expected token budget</a:t>
+            </a:r>
+            <a:endParaRPr lang="en-US" sz="1000" dirty="0"/>
+          </a:p>
+        </p:txBody>
+      </p:sp>
+      <p:sp>
+        <p:nvSpPr>
+          <p:cNvPr id="40" name="Shape 38"/>
+          <p:cNvSpPr/>
+          <p:nvPr/>
+        </p:nvSpPr>
+        <p:spPr>
+          <a:xfrm>
+            <a:off x="4754880" y="3456432"/>
+            <a:ext cx="4206240" cy="292608"/>
+          </a:xfrm>
+          <a:prstGeom prst="roundRect">
+            <a:avLst>
+              <a:gd name="adj" fmla="val 15625"/>
+            </a:avLst>
+          </a:prstGeom>
+          <a:solidFill>
+            <a:srgbClr val="F8FAFC"/>
+          </a:solidFill>
+          <a:ln w="6350">
+            <a:solidFill>
+              <a:srgbClr val="E2E8F0"/>
+            </a:solidFill>
+            <a:prstDash val="solid"/>
+          </a:ln>
+        </p:spPr>
+      </p:sp>
+      <p:sp>
+        <p:nvSpPr>
+          <p:cNvPr id="41" name="Shape 39"/>
+          <p:cNvSpPr/>
+          <p:nvPr/>
+        </p:nvSpPr>
+        <p:spPr>
+          <a:xfrm>
+            <a:off x="4828032" y="3502152"/>
+            <a:ext cx="384048" cy="201168"/>
+          </a:xfrm>
+          <a:prstGeom prst="roundRect">
+            <a:avLst>
+              <a:gd name="adj" fmla="val 18182"/>
+            </a:avLst>
+          </a:prstGeom>
+          <a:solidFill>
+            <a:srgbClr val="0D9488"/>
+          </a:solidFill>
+          <a:ln w="12700">
+            <a:solidFill>
+              <a:srgbClr val="0D9488"/>
+            </a:solidFill>
+            <a:prstDash val="solid"/>
+          </a:ln>
+        </p:spPr>
+      </p:sp>
+      <p:sp>
+        <p:nvSpPr>
+          <p:cNvPr id="42" name="Text 40"/>
+          <p:cNvSpPr/>
+          <p:nvPr/>
+        </p:nvSpPr>
+        <p:spPr>
+          <a:xfrm>
+            <a:off x="4828032" y="3502152"/>
+            <a:ext cx="384048" cy="201168"/>
+          </a:xfrm>
+          <a:prstGeom prst="rect">
+            <a:avLst/>
+          </a:prstGeom>
+          <a:noFill/>
+          <a:ln/>
+        </p:spPr>
+        <p:txBody>
+          <a:bodyPr wrap="square" rtlCol="0" anchor="ctr"/>
+          <a:lstStyle/>
+          <a:p>
+            <a:pPr algn="ctr" indent="0" marL="0">
+              <a:buNone/>
+            </a:pPr>
+            <a:r>
+              <a:rPr lang="en-US" sz="800" b="1" dirty="0">
+                <a:solidFill>
+                  <a:srgbClr val="FFFFFF"/>
+                </a:solidFill>
+                <a:latin typeface="Calibri" pitchFamily="34" charset="0"/>
+                <a:ea typeface="Calibri" pitchFamily="34" charset="-122"/>
+                <a:cs typeface="Calibri" pitchFamily="34" charset="-120"/>
+              </a:rPr>
+              <a:t>Q6a</a:t>
+            </a:r>
+            <a:endParaRPr lang="en-US" sz="800" dirty="0"/>
+          </a:p>
+        </p:txBody>
+      </p:sp>
+      <p:sp>
+        <p:nvSpPr>
+          <p:cNvPr id="43" name="Text 41"/>
+          <p:cNvSpPr/>
+          <p:nvPr/>
+        </p:nvSpPr>
+        <p:spPr>
+          <a:xfrm>
+            <a:off x="5285232" y="3456432"/>
+            <a:ext cx="3657600" cy="292608"/>
+          </a:xfrm>
+          <a:prstGeom prst="rect">
+            <a:avLst/>
+          </a:prstGeom>
+          <a:noFill/>
+          <a:ln/>
+        </p:spPr>
+        <p:txBody>
+          <a:bodyPr wrap="square" rtlCol="0" anchor="ctr"/>
+          <a:lstStyle/>
+          <a:p>
+            <a:pPr indent="0" marL="0">
+              <a:buNone/>
+            </a:pPr>
+            <a:r>
+              <a:rPr lang="en-US" sz="1000" dirty="0">
+                <a:solidFill>
+                  <a:srgbClr val="475569"/>
+                </a:solidFill>
+                <a:latin typeface="Calibri" pitchFamily="34" charset="0"/>
+                <a:ea typeface="Calibri" pitchFamily="34" charset="-122"/>
+                <a:cs typeface="Calibri" pitchFamily="34" charset="-120"/>
+              </a:rPr>
+              <a:t>Agents producing the most Must-Fix findings</a:t>
+            </a:r>
+            <a:endParaRPr lang="en-US" sz="1000" dirty="0"/>
+          </a:p>
+        </p:txBody>
+      </p:sp>
+      <p:sp>
+        <p:nvSpPr>
+          <p:cNvPr id="44" name="Shape 42"/>
+          <p:cNvSpPr/>
+          <p:nvPr/>
+        </p:nvSpPr>
+        <p:spPr>
+          <a:xfrm>
+            <a:off x="4754880" y="3803904"/>
+            <a:ext cx="4206240" cy="292608"/>
+          </a:xfrm>
+          <a:prstGeom prst="roundRect">
+            <a:avLst>
+              <a:gd name="adj" fmla="val 15625"/>
+            </a:avLst>
+          </a:prstGeom>
+          <a:solidFill>
+            <a:srgbClr val="FFFFFF"/>
+          </a:solidFill>
+          <a:ln w="6350">
+            <a:solidFill>
+              <a:srgbClr val="E2E8F0"/>
+            </a:solidFill>
+            <a:prstDash val="solid"/>
+          </a:ln>
+        </p:spPr>
+      </p:sp>
+      <p:sp>
+        <p:nvSpPr>
+          <p:cNvPr id="45" name="Shape 43"/>
+          <p:cNvSpPr/>
+          <p:nvPr/>
+        </p:nvSpPr>
+        <p:spPr>
+          <a:xfrm>
+            <a:off x="4828032" y="3849624"/>
+            <a:ext cx="384048" cy="201168"/>
+          </a:xfrm>
+          <a:prstGeom prst="roundRect">
+            <a:avLst>
+              <a:gd name="adj" fmla="val 18182"/>
+            </a:avLst>
+          </a:prstGeom>
+          <a:solidFill>
+            <a:srgbClr val="0D9488"/>
+          </a:solidFill>
+          <a:ln w="12700">
+            <a:solidFill>
+              <a:srgbClr val="0D9488"/>
+            </a:solidFill>
+            <a:prstDash val="solid"/>
+          </a:ln>
+        </p:spPr>
+      </p:sp>
+      <p:sp>
+        <p:nvSpPr>
+          <p:cNvPr id="46" name="Text 44"/>
+          <p:cNvSpPr/>
+          <p:nvPr/>
+        </p:nvSpPr>
+        <p:spPr>
+          <a:xfrm>
+            <a:off x="4828032" y="3849624"/>
+            <a:ext cx="384048" cy="201168"/>
+          </a:xfrm>
+          <a:prstGeom prst="rect">
+            <a:avLst/>
+          </a:prstGeom>
+          <a:noFill/>
+          <a:ln/>
+        </p:spPr>
+        <p:txBody>
+          <a:bodyPr wrap="square" rtlCol="0" anchor="ctr"/>
+          <a:lstStyle/>
+          <a:p>
+            <a:pPr algn="ctr" indent="0" marL="0">
+              <a:buNone/>
+            </a:pPr>
+            <a:r>
+              <a:rPr lang="en-US" sz="800" b="1" dirty="0">
+                <a:solidFill>
+                  <a:srgbClr val="FFFFFF"/>
+                </a:solidFill>
+                <a:latin typeface="Calibri" pitchFamily="34" charset="0"/>
+                <a:ea typeface="Calibri" pitchFamily="34" charset="-122"/>
+                <a:cs typeface="Calibri" pitchFamily="34" charset="-120"/>
+              </a:rPr>
+              <a:t>Q6b</a:t>
+            </a:r>
+            <a:endParaRPr lang="en-US" sz="800" dirty="0"/>
+          </a:p>
+        </p:txBody>
+      </p:sp>
+      <p:sp>
+        <p:nvSpPr>
+          <p:cNvPr id="47" name="Text 45"/>
+          <p:cNvSpPr/>
+          <p:nvPr/>
+        </p:nvSpPr>
+        <p:spPr>
+          <a:xfrm>
+            <a:off x="5285232" y="3803904"/>
+            <a:ext cx="3657600" cy="292608"/>
+          </a:xfrm>
+          <a:prstGeom prst="rect">
+            <a:avLst/>
+          </a:prstGeom>
+          <a:noFill/>
+          <a:ln/>
+        </p:spPr>
+        <p:txBody>
+          <a:bodyPr wrap="square" rtlCol="0" anchor="ctr"/>
+          <a:lstStyle/>
+          <a:p>
+            <a:pPr indent="0" marL="0">
+              <a:buNone/>
+            </a:pPr>
+            <a:r>
+              <a:rPr lang="en-US" sz="1000" dirty="0">
+                <a:solidFill>
+                  <a:srgbClr val="475569"/>
+                </a:solidFill>
+                <a:latin typeface="Calibri" pitchFamily="34" charset="0"/>
+                <a:ea typeface="Calibri" pitchFamily="34" charset="-122"/>
+                <a:cs typeface="Calibri" pitchFamily="34" charset="-120"/>
+              </a:rPr>
+              <a:t>Sessions where specialists dissented from Judge verdict</a:t>
+            </a:r>
+            <a:endParaRPr lang="en-US" sz="1000" dirty="0"/>
+          </a:p>
+        </p:txBody>
+      </p:sp>
+      <p:sp>
+        <p:nvSpPr>
+          <p:cNvPr id="48" name="Shape 46"/>
+          <p:cNvSpPr/>
+          <p:nvPr/>
+        </p:nvSpPr>
+        <p:spPr>
+          <a:xfrm>
+            <a:off x="320040" y="4645152"/>
+            <a:ext cx="8503920" cy="384048"/>
+          </a:xfrm>
+          <a:prstGeom prst="roundRect">
+            <a:avLst>
+              <a:gd name="adj" fmla="val 19048"/>
+            </a:avLst>
+          </a:prstGeom>
+          <a:solidFill>
+            <a:srgbClr val="F0FDF4"/>
+          </a:solidFill>
+          <a:ln w="6350">
+            <a:solidFill>
+              <a:srgbClr val="10B981"/>
+            </a:solidFill>
+            <a:prstDash val="solid"/>
+          </a:ln>
+        </p:spPr>
+      </p:sp>
+      <p:sp>
+        <p:nvSpPr>
+          <p:cNvPr id="49" name="Text 47"/>
+          <p:cNvSpPr/>
+          <p:nvPr/>
+        </p:nvSpPr>
+        <p:spPr>
+          <a:xfrm>
+            <a:off x="320040" y="4645152"/>
+            <a:ext cx="8503920" cy="384048"/>
+          </a:xfrm>
+          <a:prstGeom prst="rect">
+            <a:avLst/>
+          </a:prstGeom>
+          <a:noFill/>
+          <a:ln/>
+        </p:spPr>
+        <p:txBody>
+          <a:bodyPr wrap="square" rtlCol="0" anchor="ctr"/>
+          <a:lstStyle/>
+          <a:p>
+            <a:pPr algn="ctr" indent="0" marL="0">
+              <a:buNone/>
+            </a:pPr>
+            <a:r>
+              <a:rPr lang="en-US" sz="950" dirty="0">
+                <a:solidFill>
+                  <a:srgbClr val="14532D"/>
+                </a:solidFill>
+                <a:latin typeface="Calibri" pitchFamily="34" charset="0"/>
+                <a:ea typeface="Calibri" pitchFamily="34" charset="-122"/>
+                <a:cs typeface="Calibri" pitchFamily="34" charset="-120"/>
+              </a:rPr>
+              <a:t>Hybrid storage · Write-before-run (crash-safe) · SHA-256 integrity · Mock excluded from analytics · client_id + round on every row</a:t>
+            </a:r>
+            <a:endParaRPr lang="en-US" sz="950" dirty="0"/>
+          </a:p>
+        </p:txBody>
+      </p:sp>
+    </p:spTree>
+  </p:cSld>
+  <p:clrMapOvr>
+    <a:masterClrMapping/>
+  </p:clrMapOvr>
+</p:sld>
+</file>
+
 <file path=ppt/slides/slide2.xml><?xml version="1.0" encoding="utf-8"?>
 <p:sld xmlns:a="http://schemas.openxmlformats.org/drawingml/2006/main" xmlns:r="http://schemas.openxmlformats.org/officeDocument/2006/relationships" xmlns:p="http://schemas.openxmlformats.org/presentationml/2006/main">
   <p:cSld name="Slide 2">
@@ -14177,6 +15872,198 @@
         </p:nvSpPr>
         <p:spPr>
           <a:xfrm>
+            <a:off x="484632" y="5129784"/>
+            <a:ext cx="109728" cy="109728"/>
+          </a:xfrm>
+          <a:prstGeom prst="ellipse">
+            <a:avLst/>
+          </a:prstGeom>
+          <a:solidFill>
+            <a:srgbClr val="10B981"/>
+          </a:solidFill>
+          <a:ln w="12700">
+            <a:solidFill>
+              <a:srgbClr val="10B981"/>
+            </a:solidFill>
+            <a:prstDash val="solid"/>
+          </a:ln>
+        </p:spPr>
+      </p:sp>
+      <p:sp>
+        <p:nvSpPr>
+          <p:cNvPr id="33" name="Text 31"/>
+          <p:cNvSpPr/>
+          <p:nvPr/>
+        </p:nvSpPr>
+        <p:spPr>
+          <a:xfrm>
+            <a:off x="667512" y="5065776"/>
+            <a:ext cx="2395728" cy="274320"/>
+          </a:xfrm>
+          <a:prstGeom prst="rect">
+            <a:avLst/>
+          </a:prstGeom>
+          <a:noFill/>
+          <a:ln/>
+        </p:spPr>
+        <p:txBody>
+          <a:bodyPr wrap="square" rtlCol="0" anchor="ctr"/>
+          <a:lstStyle/>
+          <a:p>
+            <a:pPr indent="0" marL="0">
+              <a:buNone/>
+            </a:pPr>
+            <a:r>
+              <a:rPr lang="en-US" sz="1000" dirty="0">
+                <a:solidFill>
+                  <a:srgbClr val="CADCFC"/>
+                </a:solidFill>
+                <a:latin typeface="Calibri" pitchFamily="34" charset="0"/>
+                <a:ea typeface="Calibri" pitchFamily="34" charset="-122"/>
+                <a:cs typeface="Calibri" pitchFamily="34" charset="-120"/>
+              </a:rPr>
+              <a:t>3-table observability schema</a:t>
+            </a:r>
+            <a:endParaRPr lang="en-US" sz="1000" dirty="0"/>
+          </a:p>
+        </p:txBody>
+      </p:sp>
+      <p:sp>
+        <p:nvSpPr>
+          <p:cNvPr id="34" name="Shape 32"/>
+          <p:cNvSpPr/>
+          <p:nvPr/>
+        </p:nvSpPr>
+        <p:spPr>
+          <a:xfrm>
+            <a:off x="484632" y="5422392"/>
+            <a:ext cx="109728" cy="109728"/>
+          </a:xfrm>
+          <a:prstGeom prst="ellipse">
+            <a:avLst/>
+          </a:prstGeom>
+          <a:solidFill>
+            <a:srgbClr val="10B981"/>
+          </a:solidFill>
+          <a:ln w="12700">
+            <a:solidFill>
+              <a:srgbClr val="10B981"/>
+            </a:solidFill>
+            <a:prstDash val="solid"/>
+          </a:ln>
+        </p:spPr>
+      </p:sp>
+      <p:sp>
+        <p:nvSpPr>
+          <p:cNvPr id="35" name="Text 33"/>
+          <p:cNvSpPr/>
+          <p:nvPr/>
+        </p:nvSpPr>
+        <p:spPr>
+          <a:xfrm>
+            <a:off x="667512" y="5358384"/>
+            <a:ext cx="2395728" cy="274320"/>
+          </a:xfrm>
+          <a:prstGeom prst="rect">
+            <a:avLst/>
+          </a:prstGeom>
+          <a:noFill/>
+          <a:ln/>
+        </p:spPr>
+        <p:txBody>
+          <a:bodyPr wrap="square" rtlCol="0" anchor="ctr"/>
+          <a:lstStyle/>
+          <a:p>
+            <a:pPr indent="0" marL="0">
+              <a:buNone/>
+            </a:pPr>
+            <a:r>
+              <a:rPr lang="en-US" sz="1000" dirty="0">
+                <a:solidFill>
+                  <a:srgbClr val="CADCFC"/>
+                </a:solidFill>
+                <a:latin typeface="Calibri" pitchFamily="34" charset="0"/>
+                <a:ea typeface="Calibri" pitchFamily="34" charset="-122"/>
+                <a:cs typeface="Calibri" pitchFamily="34" charset="-120"/>
+              </a:rPr>
+              <a:t>SessionTracer — full agent lifecycle</a:t>
+            </a:r>
+            <a:endParaRPr lang="en-US" sz="1000" dirty="0"/>
+          </a:p>
+        </p:txBody>
+      </p:sp>
+      <p:sp>
+        <p:nvSpPr>
+          <p:cNvPr id="36" name="Shape 34"/>
+          <p:cNvSpPr/>
+          <p:nvPr/>
+        </p:nvSpPr>
+        <p:spPr>
+          <a:xfrm>
+            <a:off x="484632" y="5715000"/>
+            <a:ext cx="109728" cy="109728"/>
+          </a:xfrm>
+          <a:prstGeom prst="ellipse">
+            <a:avLst/>
+          </a:prstGeom>
+          <a:solidFill>
+            <a:srgbClr val="10B981"/>
+          </a:solidFill>
+          <a:ln w="12700">
+            <a:solidFill>
+              <a:srgbClr val="10B981"/>
+            </a:solidFill>
+            <a:prstDash val="solid"/>
+          </a:ln>
+        </p:spPr>
+      </p:sp>
+      <p:sp>
+        <p:nvSpPr>
+          <p:cNvPr id="37" name="Text 35"/>
+          <p:cNvSpPr/>
+          <p:nvPr/>
+        </p:nvSpPr>
+        <p:spPr>
+          <a:xfrm>
+            <a:off x="667512" y="5650992"/>
+            <a:ext cx="2395728" cy="274320"/>
+          </a:xfrm>
+          <a:prstGeom prst="rect">
+            <a:avLst/>
+          </a:prstGeom>
+          <a:noFill/>
+          <a:ln/>
+        </p:spPr>
+        <p:txBody>
+          <a:bodyPr wrap="square" rtlCol="0" anchor="ctr"/>
+          <a:lstStyle/>
+          <a:p>
+            <a:pPr indent="0" marL="0">
+              <a:buNone/>
+            </a:pPr>
+            <a:r>
+              <a:rPr lang="en-US" sz="1000" dirty="0">
+                <a:solidFill>
+                  <a:srgbClr val="CADCFC"/>
+                </a:solidFill>
+                <a:latin typeface="Calibri" pitchFamily="34" charset="0"/>
+                <a:ea typeface="Calibri" pitchFamily="34" charset="-122"/>
+                <a:cs typeface="Calibri" pitchFamily="34" charset="-120"/>
+              </a:rPr>
+              <a:t>SHA-256 trace integrity hash</a:t>
+            </a:r>
+            <a:endParaRPr lang="en-US" sz="1000" dirty="0"/>
+          </a:p>
+        </p:txBody>
+      </p:sp>
+      <p:sp>
+        <p:nvSpPr>
+          <p:cNvPr id="38" name="Shape 36"/>
+          <p:cNvSpPr/>
+          <p:nvPr/>
+        </p:nvSpPr>
+        <p:spPr>
+          <a:xfrm>
             <a:off x="3264408" y="777240"/>
             <a:ext cx="2743200" cy="438912"/>
           </a:xfrm>
@@ -14198,7 +16085,7 @@
       </p:sp>
       <p:sp>
         <p:nvSpPr>
-          <p:cNvPr id="33" name="Text 31"/>
+          <p:cNvPr id="39" name="Text 37"/>
           <p:cNvSpPr/>
           <p:nvPr/>
         </p:nvSpPr>
@@ -14237,7 +16124,7 @@
       </p:sp>
       <p:sp>
         <p:nvSpPr>
-          <p:cNvPr id="34" name="Shape 32"/>
+          <p:cNvPr id="40" name="Shape 38"/>
           <p:cNvSpPr/>
           <p:nvPr/>
         </p:nvSpPr>
@@ -14262,7 +16149,7 @@
       </p:sp>
       <p:sp>
         <p:nvSpPr>
-          <p:cNvPr id="35" name="Text 33"/>
+          <p:cNvPr id="41" name="Text 39"/>
           <p:cNvSpPr/>
           <p:nvPr/>
         </p:nvSpPr>
@@ -14301,7 +16188,7 @@
       </p:sp>
       <p:sp>
         <p:nvSpPr>
-          <p:cNvPr id="36" name="Shape 34"/>
+          <p:cNvPr id="42" name="Shape 40"/>
           <p:cNvSpPr/>
           <p:nvPr/>
         </p:nvSpPr>
@@ -14326,7 +16213,7 @@
       </p:sp>
       <p:sp>
         <p:nvSpPr>
-          <p:cNvPr id="37" name="Text 35"/>
+          <p:cNvPr id="43" name="Text 41"/>
           <p:cNvSpPr/>
           <p:nvPr/>
         </p:nvSpPr>
@@ -14365,7 +16252,7 @@
       </p:sp>
       <p:sp>
         <p:nvSpPr>
-          <p:cNvPr id="38" name="Shape 36"/>
+          <p:cNvPr id="44" name="Shape 42"/>
           <p:cNvSpPr/>
           <p:nvPr/>
         </p:nvSpPr>
@@ -14390,7 +16277,7 @@
       </p:sp>
       <p:sp>
         <p:nvSpPr>
-          <p:cNvPr id="39" name="Text 37"/>
+          <p:cNvPr id="45" name="Text 43"/>
           <p:cNvSpPr/>
           <p:nvPr/>
         </p:nvSpPr>
@@ -14429,7 +16316,7 @@
       </p:sp>
       <p:sp>
         <p:nvSpPr>
-          <p:cNvPr id="40" name="Shape 38"/>
+          <p:cNvPr id="46" name="Shape 44"/>
           <p:cNvSpPr/>
           <p:nvPr/>
         </p:nvSpPr>
@@ -14454,7 +16341,7 @@
       </p:sp>
       <p:sp>
         <p:nvSpPr>
-          <p:cNvPr id="41" name="Text 39"/>
+          <p:cNvPr id="47" name="Text 45"/>
           <p:cNvSpPr/>
           <p:nvPr/>
         </p:nvSpPr>
@@ -14493,7 +16380,7 @@
       </p:sp>
       <p:sp>
         <p:nvSpPr>
-          <p:cNvPr id="42" name="Shape 40"/>
+          <p:cNvPr id="48" name="Shape 46"/>
           <p:cNvSpPr/>
           <p:nvPr/>
         </p:nvSpPr>
@@ -14518,7 +16405,7 @@
       </p:sp>
       <p:sp>
         <p:nvSpPr>
-          <p:cNvPr id="43" name="Text 41"/>
+          <p:cNvPr id="49" name="Text 47"/>
           <p:cNvSpPr/>
           <p:nvPr/>
         </p:nvSpPr>
@@ -14549,7 +16436,7 @@
                 <a:ea typeface="Calibri" pitchFamily="34" charset="-122"/>
                 <a:cs typeface="Calibri" pitchFamily="34" charset="-120"/>
               </a:rPr>
-              <a:t>Session observability tracing</a:t>
+              <a:t>Injection layer tracing (Q1/Q2)</a:t>
             </a:r>
             <a:endParaRPr lang="en-US" sz="1000" dirty="0"/>
           </a:p>
@@ -14557,7 +16444,7 @@
       </p:sp>
       <p:sp>
         <p:nvSpPr>
-          <p:cNvPr id="44" name="Shape 42"/>
+          <p:cNvPr id="50" name="Shape 48"/>
           <p:cNvSpPr/>
           <p:nvPr/>
         </p:nvSpPr>
@@ -14582,7 +16469,7 @@
       </p:sp>
       <p:sp>
         <p:nvSpPr>
-          <p:cNvPr id="45" name="Text 43"/>
+          <p:cNvPr id="51" name="Text 49"/>
           <p:cNvSpPr/>
           <p:nvPr/>
         </p:nvSpPr>
@@ -14621,7 +16508,7 @@
       </p:sp>
       <p:sp>
         <p:nvSpPr>
-          <p:cNvPr id="46" name="Shape 44"/>
+          <p:cNvPr id="52" name="Shape 50"/>
           <p:cNvSpPr/>
           <p:nvPr/>
         </p:nvSpPr>
@@ -14646,7 +16533,7 @@
       </p:sp>
       <p:sp>
         <p:nvSpPr>
-          <p:cNvPr id="47" name="Text 45"/>
+          <p:cNvPr id="53" name="Text 51"/>
           <p:cNvSpPr/>
           <p:nvPr/>
         </p:nvSpPr>
@@ -14685,7 +16572,7 @@
       </p:sp>
       <p:sp>
         <p:nvSpPr>
-          <p:cNvPr id="48" name="Shape 46"/>
+          <p:cNvPr id="54" name="Shape 52"/>
           <p:cNvSpPr/>
           <p:nvPr/>
         </p:nvSpPr>
@@ -14710,7 +16597,7 @@
       </p:sp>
       <p:sp>
         <p:nvSpPr>
-          <p:cNvPr id="49" name="Text 47"/>
+          <p:cNvPr id="55" name="Text 53"/>
           <p:cNvSpPr/>
           <p:nvPr/>
         </p:nvSpPr>
@@ -14749,7 +16636,7 @@
       </p:sp>
       <p:sp>
         <p:nvSpPr>
-          <p:cNvPr id="50" name="Shape 48"/>
+          <p:cNvPr id="56" name="Shape 54"/>
           <p:cNvSpPr/>
           <p:nvPr/>
         </p:nvSpPr>
@@ -14776,7 +16663,7 @@
       </p:sp>
       <p:sp>
         <p:nvSpPr>
-          <p:cNvPr id="51" name="Text 49"/>
+          <p:cNvPr id="57" name="Text 55"/>
           <p:cNvSpPr/>
           <p:nvPr/>
         </p:nvSpPr>
@@ -14815,7 +16702,7 @@
       </p:sp>
       <p:sp>
         <p:nvSpPr>
-          <p:cNvPr id="52" name="Shape 50"/>
+          <p:cNvPr id="58" name="Shape 56"/>
           <p:cNvSpPr/>
           <p:nvPr/>
         </p:nvSpPr>
@@ -14840,7 +16727,7 @@
       </p:sp>
       <p:sp>
         <p:nvSpPr>
-          <p:cNvPr id="53" name="Text 51"/>
+          <p:cNvPr id="59" name="Text 57"/>
           <p:cNvSpPr/>
           <p:nvPr/>
         </p:nvSpPr>
@@ -14879,7 +16766,7 @@
       </p:sp>
       <p:sp>
         <p:nvSpPr>
-          <p:cNvPr id="54" name="Shape 52"/>
+          <p:cNvPr id="60" name="Shape 58"/>
           <p:cNvSpPr/>
           <p:nvPr/>
         </p:nvSpPr>
@@ -14904,7 +16791,7 @@
       </p:sp>
       <p:sp>
         <p:nvSpPr>
-          <p:cNvPr id="55" name="Text 53"/>
+          <p:cNvPr id="61" name="Text 59"/>
           <p:cNvSpPr/>
           <p:nvPr/>
         </p:nvSpPr>
@@ -14943,7 +16830,7 @@
       </p:sp>
       <p:sp>
         <p:nvSpPr>
-          <p:cNvPr id="56" name="Shape 54"/>
+          <p:cNvPr id="62" name="Shape 60"/>
           <p:cNvSpPr/>
           <p:nvPr/>
         </p:nvSpPr>
@@ -14968,7 +16855,7 @@
       </p:sp>
       <p:sp>
         <p:nvSpPr>
-          <p:cNvPr id="57" name="Text 55"/>
+          <p:cNvPr id="63" name="Text 61"/>
           <p:cNvSpPr/>
           <p:nvPr/>
         </p:nvSpPr>
@@ -15007,7 +16894,7 @@
       </p:sp>
       <p:sp>
         <p:nvSpPr>
-          <p:cNvPr id="58" name="Shape 56"/>
+          <p:cNvPr id="64" name="Shape 62"/>
           <p:cNvSpPr/>
           <p:nvPr/>
         </p:nvSpPr>
@@ -15032,7 +16919,7 @@
       </p:sp>
       <p:sp>
         <p:nvSpPr>
-          <p:cNvPr id="59" name="Text 57"/>
+          <p:cNvPr id="65" name="Text 63"/>
           <p:cNvSpPr/>
           <p:nvPr/>
         </p:nvSpPr>
@@ -15071,7 +16958,7 @@
       </p:sp>
       <p:sp>
         <p:nvSpPr>
-          <p:cNvPr id="60" name="Shape 58"/>
+          <p:cNvPr id="66" name="Shape 64"/>
           <p:cNvSpPr/>
           <p:nvPr/>
         </p:nvSpPr>
@@ -15096,7 +16983,7 @@
       </p:sp>
       <p:sp>
         <p:nvSpPr>
-          <p:cNvPr id="61" name="Text 59"/>
+          <p:cNvPr id="67" name="Text 65"/>
           <p:cNvSpPr/>
           <p:nvPr/>
         </p:nvSpPr>
@@ -15135,7 +17022,7 @@
       </p:sp>
       <p:sp>
         <p:nvSpPr>
-          <p:cNvPr id="62" name="Shape 60"/>
+          <p:cNvPr id="68" name="Shape 66"/>
           <p:cNvSpPr/>
           <p:nvPr/>
         </p:nvSpPr>
@@ -15160,7 +17047,7 @@
       </p:sp>
       <p:sp>
         <p:nvSpPr>
-          <p:cNvPr id="63" name="Text 61"/>
+          <p:cNvPr id="69" name="Text 67"/>
           <p:cNvSpPr/>
           <p:nvPr/>
         </p:nvSpPr>
@@ -15199,7 +17086,7 @@
       </p:sp>
       <p:sp>
         <p:nvSpPr>
-          <p:cNvPr id="64" name="Shape 62"/>
+          <p:cNvPr id="70" name="Shape 68"/>
           <p:cNvSpPr/>
           <p:nvPr/>
         </p:nvSpPr>
@@ -15224,7 +17111,7 @@
       </p:sp>
       <p:sp>
         <p:nvSpPr>
-          <p:cNvPr id="65" name="Text 63"/>
+          <p:cNvPr id="71" name="Text 69"/>
           <p:cNvSpPr/>
           <p:nvPr/>
         </p:nvSpPr>

</xml_diff>